<commit_message>
fix(fdemo): the showcase deck is rebuilt from a rehearsal of the fixed demo, after two runs in a row
Review S6b r1: three rehearsals in a row on this lane's full stack, no
reset, against a MongoDB target put back into the 28799 state: full,
--skip-oracle --skip-scanner, then --console, every one PASS. The deck is
built --strict from the --console run at b0bea88 (3:17, API path 3:04);
a second build is byte-identical. The presenter script's status and the
deviation log record the runs.
</commit_message>
<xml_diff>
--- a/docs/demo/dps-showcase.pptx
+++ b/docs/demo/dps-showcase.pptx
@@ -5104,7 +5104,7 @@
                 </a:solidFill>
                 <a:latin typeface="Helvetica Neue"/>
               </a:rPr>
-              <a:t>Built from the rehearsal of 15 October 2026: the scripted demo ran end to end in 3:25.</a:t>
+              <a:t>Built from the rehearsal of 15 October 2026: the scripted demo ran end to end in 3:17.</a:t>
             </a:r>
           </a:p>
         </p:txBody>
@@ -5143,7 +5143,7 @@
                 </a:solidFill>
                 <a:latin typeface="Helvetica Neue"/>
               </a:rPr>
-              <a:t>Data Privacy Services · Privacy Console · rehearsal 2026-10-15 18:28 UTC · commit 37ec781</a:t>
+              <a:t>Data Privacy Services · Privacy Console · rehearsal 2026-10-15 21:29 UTC · commit b0bea88</a:t>
             </a:r>
           </a:p>
         </p:txBody>
@@ -5644,7 +5644,7 @@
                 </a:solidFill>
                 <a:latin typeface="Helvetica Neue"/>
               </a:rPr>
-              <a:t>Data Privacy Services · Privacy Console · rehearsal 2026-10-15 18:28 UTC · commit 37ec781</a:t>
+              <a:t>Data Privacy Services · Privacy Console · rehearsal 2026-10-15 21:29 UTC · commit b0bea88</a:t>
             </a:r>
           </a:p>
         </p:txBody>
@@ -6394,7 +6394,7 @@
                 </a:solidFill>
                 <a:latin typeface="Helvetica Neue"/>
               </a:rPr>
-              <a:t>Data Privacy Services · Privacy Console · rehearsal 2026-10-15 18:28 UTC · commit 37ec781</a:t>
+              <a:t>Data Privacy Services · Privacy Console · rehearsal 2026-10-15 21:29 UTC · commit b0bea88</a:t>
             </a:r>
           </a:p>
         </p:txBody>
@@ -8295,7 +8295,7 @@
                 </a:solidFill>
                 <a:latin typeface="Helvetica Neue"/>
               </a:rPr>
-              <a:t>Data Privacy Services · Privacy Console · rehearsal 2026-10-15 18:28 UTC · commit 37ec781</a:t>
+              <a:t>Data Privacy Services · Privacy Console · rehearsal 2026-10-15 21:29 UTC · commit b0bea88</a:t>
             </a:r>
           </a:p>
         </p:txBody>
@@ -8909,7 +8909,7 @@
                 </a:solidFill>
                 <a:latin typeface="Helvetica Neue"/>
               </a:rPr>
-              <a:t>Data Privacy Services · Privacy Console · rehearsal 2026-10-15 18:28 UTC · commit 37ec781</a:t>
+              <a:t>Data Privacy Services · Privacy Console · rehearsal 2026-10-15 21:29 UTC · commit b0bea88</a:t>
             </a:r>
           </a:p>
         </p:txBody>
@@ -9526,7 +9526,7 @@
                 </a:solidFill>
                 <a:latin typeface="Helvetica Neue"/>
               </a:rPr>
-              <a:t>Data Privacy Services · Privacy Console · rehearsal 2026-10-15 18:28 UTC · commit 37ec781</a:t>
+              <a:t>Data Privacy Services · Privacy Console · rehearsal 2026-10-15 21:29 UTC · commit b0bea88</a:t>
             </a:r>
           </a:p>
         </p:txBody>
@@ -11230,7 +11230,7 @@
                 </a:solidFill>
                 <a:latin typeface="Helvetica Neue"/>
               </a:rPr>
-              <a:t>Data Privacy Services · Privacy Console · rehearsal 2026-10-15 18:28 UTC · commit 37ec781</a:t>
+              <a:t>Data Privacy Services · Privacy Console · rehearsal 2026-10-15 21:29 UTC · commit b0bea88</a:t>
             </a:r>
           </a:p>
         </p:txBody>
@@ -12247,7 +12247,7 @@
                 </a:solidFill>
                 <a:latin typeface="Helvetica Neue"/>
               </a:rPr>
-              <a:t>Data Privacy Services · Privacy Console · rehearsal 2026-10-15 18:28 UTC · commit 37ec781</a:t>
+              <a:t>Data Privacy Services · Privacy Console · rehearsal 2026-10-15 21:29 UTC · commit b0bea88</a:t>
             </a:r>
           </a:p>
         </p:txBody>
@@ -13085,7 +13085,7 @@
                 </a:solidFill>
                 <a:latin typeface="Helvetica Neue"/>
               </a:rPr>
-              <a:t>Data Privacy Services · Privacy Console · rehearsal 2026-10-15 18:28 UTC · commit 37ec781</a:t>
+              <a:t>Data Privacy Services · Privacy Console · rehearsal 2026-10-15 21:29 UTC · commit b0bea88</a:t>
             </a:r>
           </a:p>
         </p:txBody>
@@ -13376,7 +13376,7 @@
                 </a:solidFill>
                 <a:latin typeface="Helvetica Neue"/>
               </a:rPr>
-              <a:t>930.9 rows/s · verified</a:t>
+              <a:t>949.6 rows/s · verified</a:t>
             </a:r>
           </a:p>
         </p:txBody>
@@ -13456,7 +13456,7 @@
                 </a:solidFill>
                 <a:latin typeface="Helvetica Neue"/>
               </a:rPr>
-              <a:t>353.8 rows/s · verified</a:t>
+              <a:t>400.0 rows/s · verified</a:t>
             </a:r>
           </a:p>
         </p:txBody>
@@ -13536,7 +13536,7 @@
                 </a:solidFill>
                 <a:latin typeface="Helvetica Neue"/>
               </a:rPr>
-              <a:t>246.3 rows/s · verified</a:t>
+              <a:t>276.0 rows/s · verified</a:t>
             </a:r>
           </a:p>
         </p:txBody>
@@ -14509,7 +14509,7 @@
                 </a:solidFill>
                 <a:latin typeface="Helvetica Neue"/>
               </a:rPr>
-              <a:t>Data Privacy Services · Privacy Console · rehearsal 2026-10-15 18:28 UTC · commit 37ec781</a:t>
+              <a:t>Data Privacy Services · Privacy Console · rehearsal 2026-10-15 21:29 UTC · commit b0bea88</a:t>
             </a:r>
           </a:p>
         </p:txBody>
@@ -15241,7 +15241,7 @@
                 </a:solidFill>
                 <a:latin typeface="Helvetica Neue"/>
               </a:rPr>
-              <a:t>Data Privacy Services · Privacy Console · rehearsal 2026-10-15 18:28 UTC · commit 37ec781</a:t>
+              <a:t>Data Privacy Services · Privacy Console · rehearsal 2026-10-15 21:29 UTC · commit b0bea88</a:t>
             </a:r>
           </a:p>
         </p:txBody>
@@ -15487,7 +15487,7 @@
                 </a:solidFill>
                 <a:latin typeface="Helvetica Neue"/>
               </a:rPr>
-              <a:t>0.96</a:t>
+              <a:t>0.97</a:t>
             </a:r>
           </a:p>
           <a:p>
@@ -15546,7 +15546,7 @@
         <p:spPr>
           <a:xfrm>
             <a:off x="694944" y="3520440"/>
-            <a:ext cx="3185505" cy="91440"/>
+            <a:ext cx="3225669" cy="91440"/>
           </a:xfrm>
           <a:prstGeom prst="rect">
             <a:avLst/>
@@ -15705,7 +15705,7 @@
                 </a:solidFill>
                 <a:latin typeface="Helvetica Neue"/>
               </a:rPr>
-              <a:t>1.50</a:t>
+              <a:t>1.43</a:t>
             </a:r>
           </a:p>
           <a:p>
@@ -15785,7 +15785,7 @@
                 </a:solidFill>
                 <a:latin typeface="Helvetica Neue"/>
               </a:rPr>
-              <a:t>0.50</a:t>
+              <a:t>0.48</a:t>
             </a:r>
           </a:p>
           <a:p>
@@ -15865,7 +15865,7 @@
                 </a:solidFill>
                 <a:latin typeface="Helvetica Neue"/>
               </a:rPr>
-              <a:t>0.97</a:t>
+              <a:t>0.99</a:t>
             </a:r>
           </a:p>
           <a:p>
@@ -16016,7 +16016,7 @@
                 </a:solidFill>
                 <a:latin typeface="Helvetica Neue"/>
               </a:rPr>
-              <a:t>Data Privacy Services · Privacy Console · rehearsal 2026-10-15 18:28 UTC · commit 37ec781</a:t>
+              <a:t>Data Privacy Services · Privacy Console · rehearsal 2026-10-15 21:29 UTC · commit b0bea88</a:t>
             </a:r>
           </a:p>
         </p:txBody>

</xml_diff>

<commit_message>
fix(release): the showcase deck is rebuilt from the v1.0.0 rehearsal; HANDOFF states T3's egress behaviour
The committed deck was the 15 October fdemo build: its title slide read v0.2.0, every footer named
commit b0bea88, and it claimed an end-to-end run the v1.0.0 tree could not repeat. Rebuilt with
tools/build_deck.py --strict from the rehearsal of c7ad14f (demo_seed --reseed, then e2e_demo
--console: S1-S12 PASS in 3:01, 18 console screenshots): v1.0.0, commit c7ad14f, 3:01.
tests/test_deck.py 43 passed. The Keynote PDF review stays with the owner.

HANDOFF's T3 paragraph now says what the egress verifier scans after the FINAL r1 fix and which
calls still fail closed.
</commit_message>
<xml_diff>
--- a/docs/demo/dps-showcase.pptx
+++ b/docs/demo/dps-showcase.pptx
@@ -4910,7 +4910,7 @@
                 </a:solidFill>
                 <a:latin typeface="Helvetica Neue"/>
               </a:rPr>
-              <a:t>PRIVACY CONSOLE · v0.2.0</a:t>
+              <a:t>PRIVACY CONSOLE · v1.0.0</a:t>
             </a:r>
           </a:p>
         </p:txBody>
@@ -5104,7 +5104,7 @@
                 </a:solidFill>
                 <a:latin typeface="Helvetica Neue"/>
               </a:rPr>
-              <a:t>Built from the rehearsal of 15 October 2026: the scripted demo ran end to end in 3:17.</a:t>
+              <a:t>Built from the rehearsal of 16 October 2026: the scripted demo ran end to end in 3:01.</a:t>
             </a:r>
           </a:p>
         </p:txBody>
@@ -5143,7 +5143,7 @@
                 </a:solidFill>
                 <a:latin typeface="Helvetica Neue"/>
               </a:rPr>
-              <a:t>Data Privacy Services · Privacy Console · rehearsal 2026-10-15 21:29 UTC · commit b0bea88</a:t>
+              <a:t>Data Privacy Services · Privacy Console · rehearsal 2026-10-16 05:34 UTC · commit c7ad14f</a:t>
             </a:r>
           </a:p>
         </p:txBody>
@@ -5644,7 +5644,7 @@
                 </a:solidFill>
                 <a:latin typeface="Helvetica Neue"/>
               </a:rPr>
-              <a:t>Data Privacy Services · Privacy Console · rehearsal 2026-10-15 21:29 UTC · commit b0bea88</a:t>
+              <a:t>Data Privacy Services · Privacy Console · rehearsal 2026-10-16 05:34 UTC · commit c7ad14f</a:t>
             </a:r>
           </a:p>
         </p:txBody>
@@ -6394,7 +6394,7 @@
                 </a:solidFill>
                 <a:latin typeface="Helvetica Neue"/>
               </a:rPr>
-              <a:t>Data Privacy Services · Privacy Console · rehearsal 2026-10-15 21:29 UTC · commit b0bea88</a:t>
+              <a:t>Data Privacy Services · Privacy Console · rehearsal 2026-10-16 05:34 UTC · commit c7ad14f</a:t>
             </a:r>
           </a:p>
         </p:txBody>
@@ -8295,7 +8295,7 @@
                 </a:solidFill>
                 <a:latin typeface="Helvetica Neue"/>
               </a:rPr>
-              <a:t>Data Privacy Services · Privacy Console · rehearsal 2026-10-15 21:29 UTC · commit b0bea88</a:t>
+              <a:t>Data Privacy Services · Privacy Console · rehearsal 2026-10-16 05:34 UTC · commit c7ad14f</a:t>
             </a:r>
           </a:p>
         </p:txBody>
@@ -8909,7 +8909,7 @@
                 </a:solidFill>
                 <a:latin typeface="Helvetica Neue"/>
               </a:rPr>
-              <a:t>Data Privacy Services · Privacy Console · rehearsal 2026-10-15 21:29 UTC · commit b0bea88</a:t>
+              <a:t>Data Privacy Services · Privacy Console · rehearsal 2026-10-16 05:34 UTC · commit c7ad14f</a:t>
             </a:r>
           </a:p>
         </p:txBody>
@@ -9526,7 +9526,7 @@
                 </a:solidFill>
                 <a:latin typeface="Helvetica Neue"/>
               </a:rPr>
-              <a:t>Data Privacy Services · Privacy Console · rehearsal 2026-10-15 21:29 UTC · commit b0bea88</a:t>
+              <a:t>Data Privacy Services · Privacy Console · rehearsal 2026-10-16 05:34 UTC · commit c7ad14f</a:t>
             </a:r>
           </a:p>
         </p:txBody>
@@ -11230,7 +11230,7 @@
                 </a:solidFill>
                 <a:latin typeface="Helvetica Neue"/>
               </a:rPr>
-              <a:t>Data Privacy Services · Privacy Console · rehearsal 2026-10-15 21:29 UTC · commit b0bea88</a:t>
+              <a:t>Data Privacy Services · Privacy Console · rehearsal 2026-10-16 05:34 UTC · commit c7ad14f</a:t>
             </a:r>
           </a:p>
         </p:txBody>
@@ -12247,7 +12247,7 @@
                 </a:solidFill>
                 <a:latin typeface="Helvetica Neue"/>
               </a:rPr>
-              <a:t>Data Privacy Services · Privacy Console · rehearsal 2026-10-15 21:29 UTC · commit b0bea88</a:t>
+              <a:t>Data Privacy Services · Privacy Console · rehearsal 2026-10-16 05:34 UTC · commit c7ad14f</a:t>
             </a:r>
           </a:p>
         </p:txBody>
@@ -13085,7 +13085,7 @@
                 </a:solidFill>
                 <a:latin typeface="Helvetica Neue"/>
               </a:rPr>
-              <a:t>Data Privacy Services · Privacy Console · rehearsal 2026-10-15 21:29 UTC · commit b0bea88</a:t>
+              <a:t>Data Privacy Services · Privacy Console · rehearsal 2026-10-16 05:34 UTC · commit c7ad14f</a:t>
             </a:r>
           </a:p>
         </p:txBody>
@@ -13376,7 +13376,7 @@
                 </a:solidFill>
                 <a:latin typeface="Helvetica Neue"/>
               </a:rPr>
-              <a:t>949.6 rows/s · verified</a:t>
+              <a:t>1,338.8 rows/s · verified</a:t>
             </a:r>
           </a:p>
         </p:txBody>
@@ -13456,7 +13456,7 @@
                 </a:solidFill>
                 <a:latin typeface="Helvetica Neue"/>
               </a:rPr>
-              <a:t>400.0 rows/s · verified</a:t>
+              <a:t>455.8 rows/s · verified</a:t>
             </a:r>
           </a:p>
         </p:txBody>
@@ -13536,7 +13536,7 @@
                 </a:solidFill>
                 <a:latin typeface="Helvetica Neue"/>
               </a:rPr>
-              <a:t>276.0 rows/s · verified</a:t>
+              <a:t>322.1 rows/s · verified</a:t>
             </a:r>
           </a:p>
         </p:txBody>
@@ -14509,7 +14509,7 @@
                 </a:solidFill>
                 <a:latin typeface="Helvetica Neue"/>
               </a:rPr>
-              <a:t>Data Privacy Services · Privacy Console · rehearsal 2026-10-15 21:29 UTC · commit b0bea88</a:t>
+              <a:t>Data Privacy Services · Privacy Console · rehearsal 2026-10-16 05:34 UTC · commit c7ad14f</a:t>
             </a:r>
           </a:p>
         </p:txBody>
@@ -15241,7 +15241,7 @@
                 </a:solidFill>
                 <a:latin typeface="Helvetica Neue"/>
               </a:rPr>
-              <a:t>Data Privacy Services · Privacy Console · rehearsal 2026-10-15 21:29 UTC · commit b0bea88</a:t>
+              <a:t>Data Privacy Services · Privacy Console · rehearsal 2026-10-16 05:34 UTC · commit c7ad14f</a:t>
             </a:r>
           </a:p>
         </p:txBody>
@@ -15546,7 +15546,7 @@
         <p:spPr>
           <a:xfrm>
             <a:off x="694944" y="3520440"/>
-            <a:ext cx="3225669" cy="91440"/>
+            <a:ext cx="3213055" cy="91440"/>
           </a:xfrm>
           <a:prstGeom prst="rect">
             <a:avLst/>
@@ -15705,7 +15705,7 @@
                 </a:solidFill>
                 <a:latin typeface="Helvetica Neue"/>
               </a:rPr>
-              <a:t>1.43</a:t>
+              <a:t>1.44</a:t>
             </a:r>
           </a:p>
           <a:p>
@@ -15785,7 +15785,7 @@
                 </a:solidFill>
                 <a:latin typeface="Helvetica Neue"/>
               </a:rPr>
-              <a:t>0.48</a:t>
+              <a:t>0.51</a:t>
             </a:r>
           </a:p>
           <a:p>
@@ -15865,7 +15865,7 @@
                 </a:solidFill>
                 <a:latin typeface="Helvetica Neue"/>
               </a:rPr>
-              <a:t>0.99</a:t>
+              <a:t>0.98</a:t>
             </a:r>
           </a:p>
           <a:p>
@@ -16016,7 +16016,7 @@
                 </a:solidFill>
                 <a:latin typeface="Helvetica Neue"/>
               </a:rPr>
-              <a:t>Data Privacy Services · Privacy Console · rehearsal 2026-10-15 21:29 UTC · commit b0bea88</a:t>
+              <a:t>Data Privacy Services · Privacy Console · rehearsal 2026-10-16 05:34 UTC · commit c7ad14f</a:t>
             </a:r>
           </a:p>
         </p:txBody>

</xml_diff>